<commit_message>
CPC: add AI scope annex, LLM-placement diagram (fig 4), and AI roadmap deck slide
Co-Authored-By: Claude Opus 5 <noreply@anthropic.com>
</commit_message>
<xml_diff>
--- a/cpc/docs/CPC-Client-Presentation.pptx
+++ b/cpc/docs/CPC-Client-Presentation.pptx
@@ -19,6 +19,7 @@
     <p:sldId id="267" r:id="rId18"/>
     <p:sldId id="268" r:id="rId19"/>
     <p:sldId id="269" r:id="rId20"/>
+    <p:sldId id="270" r:id="rId21"/>
   </p:sldIdLst>
   <p:sldSz cx="12191695" cy="6858000" type="screen4x3"/>
   <p:notesSz cx="6858000" cy="9144000"/>
@@ -6840,7 +6841,7 @@
                 </a:solidFill>
                 <a:latin typeface="Calibri"/>
               </a:rPr>
-              <a:t>Delivery plan</a:t>
+              <a:t>AI roadmap: intelligence on top, determinism underneath</a:t>
             </a:r>
           </a:p>
         </p:txBody>
@@ -6879,74 +6880,21 @@
                 </a:solidFill>
                 <a:latin typeface="Calibri"/>
               </a:rPr>
-              <a:t>Indicative — refined in a one-week discovery that validates landscape-dependent items</a:t>
-            </a:r>
-          </a:p>
-        </p:txBody>
-      </p:sp>
-      <p:sp>
-        <p:nvSpPr>
-          <p:cNvPr id="5" name="Oval 4"/>
+              <a:t>The audited history and the rules core make AI safe here — the LLM proposes and explains; BRFplus decides; the core writes</a:t>
+            </a:r>
+          </a:p>
+        </p:txBody>
+      </p:sp>
+      <p:sp>
+        <p:nvSpPr>
+          <p:cNvPr id="5" name="Rounded Rectangle 4"/>
           <p:cNvSpPr/>
           <p:nvPr/>
         </p:nvSpPr>
         <p:spPr>
           <a:xfrm>
-            <a:off x="640080" y="1847088"/>
-            <a:ext cx="512064" cy="512064"/>
-          </a:xfrm>
-          <a:prstGeom prst="ellipse">
-            <a:avLst/>
-          </a:prstGeom>
-          <a:solidFill>
-            <a:srgbClr val="B8791A"/>
-          </a:solidFill>
-          <a:ln>
-            <a:noFill/>
-          </a:ln>
-          <a:effectLst/>
-        </p:spPr>
-        <p:style>
-          <a:lnRef idx="1">
-            <a:schemeClr val="accent1"/>
-          </a:lnRef>
-          <a:fillRef idx="3">
-            <a:schemeClr val="accent1"/>
-          </a:fillRef>
-          <a:effectRef idx="2">
-            <a:schemeClr val="accent1"/>
-          </a:effectRef>
-          <a:fontRef idx="minor">
-            <a:schemeClr val="lt1"/>
-          </a:fontRef>
-        </p:style>
-        <p:txBody>
-          <a:bodyPr rtlCol="0" anchor="ctr" wrap="none" lIns="0" rIns="0" tIns="0" bIns="0"/>
-          <a:lstStyle/>
-          <a:p>
-            <a:pPr algn="ctr"/>
-            <a:r>
-              <a:rPr sz="1400" b="1">
-                <a:solidFill>
-                  <a:srgbClr val="FFFFFF"/>
-                </a:solidFill>
-                <a:latin typeface="Calibri"/>
-              </a:rPr>
-              <a:t>0</a:t>
-            </a:r>
-          </a:p>
-        </p:txBody>
-      </p:sp>
-      <p:sp>
-        <p:nvSpPr>
-          <p:cNvPr id="6" name="Rounded Rectangle 5"/>
-          <p:cNvSpPr/>
-          <p:nvPr/>
-        </p:nvSpPr>
-        <p:spPr>
-          <a:xfrm>
-            <a:off x="1417320" y="1645920"/>
-            <a:ext cx="10195560" cy="914400"/>
+            <a:off x="548640" y="1600200"/>
+            <a:ext cx="3611880" cy="3063240"/>
           </a:xfrm>
           <a:prstGeom prst="roundRect">
             <a:avLst>
@@ -6985,161 +6933,209 @@
       </p:sp>
       <p:sp>
         <p:nvSpPr>
+          <p:cNvPr id="6" name="TextBox 5"/>
+          <p:cNvSpPr txBox="1"/>
+          <p:nvPr/>
+        </p:nvSpPr>
+        <p:spPr>
+          <a:xfrm>
+            <a:off x="777240" y="1783080"/>
+            <a:ext cx="3200400" cy="320040"/>
+          </a:xfrm>
+          <a:prstGeom prst="rect">
+            <a:avLst/>
+          </a:prstGeom>
+          <a:noFill/>
+        </p:spPr>
+        <p:txBody>
+          <a:bodyPr wrap="square" lIns="0" rIns="0" tIns="0" bIns="0" anchor="t">
+            <a:spAutoFit/>
+          </a:bodyPr>
+          <a:lstStyle/>
+          <a:p>
+            <a:pPr algn="l">
+              <a:spcAft>
+                <a:spcPts val="600"/>
+              </a:spcAft>
+            </a:pPr>
+            <a:r>
+              <a:rPr sz="1450" b="1" i="0">
+                <a:solidFill>
+                  <a:srgbClr val="6B4FBB"/>
+                </a:solidFill>
+                <a:latin typeface="Calibri"/>
+              </a:rPr>
+              <a:t>Wave 1 · Near-term</a:t>
+            </a:r>
+          </a:p>
+        </p:txBody>
+      </p:sp>
+      <p:sp>
+        <p:nvSpPr>
           <p:cNvPr id="7" name="TextBox 6"/>
           <p:cNvSpPr txBox="1"/>
           <p:nvPr/>
         </p:nvSpPr>
         <p:spPr>
           <a:xfrm>
-            <a:off x="1691640" y="1755648"/>
-            <a:ext cx="5943600" cy="365760"/>
-          </a:xfrm>
-          <a:prstGeom prst="rect">
-            <a:avLst/>
-          </a:prstGeom>
-          <a:noFill/>
-        </p:spPr>
-        <p:txBody>
-          <a:bodyPr wrap="square" lIns="0" rIns="0" tIns="0" bIns="0" anchor="t">
-            <a:spAutoFit/>
-          </a:bodyPr>
-          <a:lstStyle/>
-          <a:p>
-            <a:pPr algn="l">
-              <a:spcAft>
-                <a:spcPts val="0"/>
-              </a:spcAft>
-            </a:pPr>
-            <a:r>
-              <a:rPr sz="1500" b="1" i="0">
+            <a:off x="777240" y="2240280"/>
+            <a:ext cx="3200400" cy="320040"/>
+          </a:xfrm>
+          <a:prstGeom prst="rect">
+            <a:avLst/>
+          </a:prstGeom>
+          <a:noFill/>
+        </p:spPr>
+        <p:txBody>
+          <a:bodyPr wrap="square" lIns="0" rIns="0" tIns="0" bIns="0" anchor="t">
+            <a:spAutoFit/>
+          </a:bodyPr>
+          <a:lstStyle/>
+          <a:p>
+            <a:pPr algn="l">
+              <a:spcAft>
+                <a:spcPts val="600"/>
+              </a:spcAft>
+            </a:pPr>
+            <a:r>
+              <a:rPr sz="1250" b="1" i="0">
                 <a:solidFill>
                   <a:srgbClr val="1A2420"/>
                 </a:solidFill>
                 <a:latin typeface="Calibri"/>
               </a:rPr>
-              <a:t>Discovery &amp; validation   </a:t>
-            </a:r>
-          </a:p>
-          <a:p>
-            <a:pPr algn="l">
-              <a:spcAft>
-                <a:spcPts val="0"/>
+              <a:t>Natural-language preferences</a:t>
+            </a:r>
+          </a:p>
+        </p:txBody>
+      </p:sp>
+      <p:sp>
+        <p:nvSpPr>
+          <p:cNvPr id="8" name="TextBox 7"/>
+          <p:cNvSpPr txBox="1"/>
+          <p:nvPr/>
+        </p:nvSpPr>
+        <p:spPr>
+          <a:xfrm>
+            <a:off x="777240" y="2532888"/>
+            <a:ext cx="3200400" cy="868680"/>
+          </a:xfrm>
+          <a:prstGeom prst="rect">
+            <a:avLst/>
+          </a:prstGeom>
+          <a:noFill/>
+        </p:spPr>
+        <p:txBody>
+          <a:bodyPr wrap="square" lIns="0" rIns="0" tIns="0" bIns="0" anchor="t">
+            <a:spAutoFit/>
+          </a:bodyPr>
+          <a:lstStyle/>
+          <a:p>
+            <a:pPr algn="l">
+              <a:spcAft>
+                <a:spcPts val="600"/>
+              </a:spcAft>
+            </a:pPr>
+            <a:r>
+              <a:rPr sz="1030" b="0" i="0">
+                <a:solidFill>
+                  <a:srgbClr val="5B6A64"/>
+                </a:solidFill>
+                <a:latin typeface="Calibri"/>
+              </a:rPr>
+              <a:t>“Stop calling me, keep outage texts” → proposed change → customer confirms → normal trusted path</a:t>
+            </a:r>
+          </a:p>
+        </p:txBody>
+      </p:sp>
+      <p:sp>
+        <p:nvSpPr>
+          <p:cNvPr id="9" name="TextBox 8"/>
+          <p:cNvSpPr txBox="1"/>
+          <p:nvPr/>
+        </p:nvSpPr>
+        <p:spPr>
+          <a:xfrm>
+            <a:off x="777240" y="3447288"/>
+            <a:ext cx="3200400" cy="320040"/>
+          </a:xfrm>
+          <a:prstGeom prst="rect">
+            <a:avLst/>
+          </a:prstGeom>
+          <a:noFill/>
+        </p:spPr>
+        <p:txBody>
+          <a:bodyPr wrap="square" lIns="0" rIns="0" tIns="0" bIns="0" anchor="t">
+            <a:spAutoFit/>
+          </a:bodyPr>
+          <a:lstStyle/>
+          <a:p>
+            <a:pPr algn="l">
+              <a:spcAft>
+                <a:spcPts val="600"/>
               </a:spcAft>
             </a:pPr>
             <a:r>
               <a:rPr sz="1250" b="1" i="0">
                 <a:solidFill>
-                  <a:srgbClr val="084A3E"/>
-                </a:solidFill>
-                <a:latin typeface="Calibri"/>
-              </a:rPr>
-              <a:t>~1 wk</a:t>
-            </a:r>
-          </a:p>
-        </p:txBody>
-      </p:sp>
-      <p:sp>
-        <p:nvSpPr>
-          <p:cNvPr id="8" name="TextBox 7"/>
-          <p:cNvSpPr txBox="1"/>
-          <p:nvPr/>
-        </p:nvSpPr>
-        <p:spPr>
-          <a:xfrm>
-            <a:off x="1691640" y="2121408"/>
-            <a:ext cx="9692640" cy="411480"/>
-          </a:xfrm>
-          <a:prstGeom prst="rect">
-            <a:avLst/>
-          </a:prstGeom>
-          <a:noFill/>
-        </p:spPr>
-        <p:txBody>
-          <a:bodyPr wrap="square" lIns="0" rIns="0" tIns="0" bIns="0" anchor="t">
-            <a:spAutoFit/>
-          </a:bodyPr>
-          <a:lstStyle/>
-          <a:p>
-            <a:pPr algn="l">
-              <a:spcAft>
-                <a:spcPts val="600"/>
-              </a:spcAft>
-            </a:pPr>
-            <a:r>
-              <a:rPr sz="1150" b="0" i="0">
+                  <a:srgbClr val="1A2420"/>
+                </a:solidFill>
+                <a:latin typeface="Calibri"/>
+              </a:rPr>
+              <a:t>CSR copilot (Service Cloud V2)</a:t>
+            </a:r>
+          </a:p>
+        </p:txBody>
+      </p:sp>
+      <p:sp>
+        <p:nvSpPr>
+          <p:cNvPr id="10" name="TextBox 9"/>
+          <p:cNvSpPr txBox="1"/>
+          <p:nvPr/>
+        </p:nvSpPr>
+        <p:spPr>
+          <a:xfrm>
+            <a:off x="777240" y="3739896"/>
+            <a:ext cx="3200400" cy="868680"/>
+          </a:xfrm>
+          <a:prstGeom prst="rect">
+            <a:avLst/>
+          </a:prstGeom>
+          <a:noFill/>
+        </p:spPr>
+        <p:txBody>
+          <a:bodyPr wrap="square" lIns="0" rIns="0" tIns="0" bIns="0" anchor="t">
+            <a:spAutoFit/>
+          </a:bodyPr>
+          <a:lstStyle/>
+          <a:p>
+            <a:pPr algn="l">
+              <a:spcAft>
+                <a:spcPts val="600"/>
+              </a:spcAft>
+            </a:pPr>
+            <a:r>
+              <a:rPr sz="1030" b="0" i="0">
                 <a:solidFill>
                   <a:srgbClr val="5B6A64"/>
                 </a:solidFill>
                 <a:latin typeface="Calibri"/>
               </a:rPr>
-              <a:t>Confirm S/4 release APIs &amp; event mechanism, option A/B, master-data source, workbook sign-off</a:t>
-            </a:r>
-          </a:p>
-        </p:txBody>
-      </p:sp>
-      <p:sp>
-        <p:nvSpPr>
-          <p:cNvPr id="9" name="Oval 8"/>
+              <a:t>Audit-trail summaries, “why no letters?” answers, case-note drafts — check Joule extensibility first</a:t>
+            </a:r>
+          </a:p>
+        </p:txBody>
+      </p:sp>
+      <p:sp>
+        <p:nvSpPr>
+          <p:cNvPr id="11" name="Rounded Rectangle 10"/>
           <p:cNvSpPr/>
           <p:nvPr/>
         </p:nvSpPr>
         <p:spPr>
           <a:xfrm>
-            <a:off x="640080" y="2926080"/>
-            <a:ext cx="512064" cy="512064"/>
-          </a:xfrm>
-          <a:prstGeom prst="ellipse">
-            <a:avLst/>
-          </a:prstGeom>
-          <a:solidFill>
-            <a:srgbClr val="0A6E5C"/>
-          </a:solidFill>
-          <a:ln>
-            <a:noFill/>
-          </a:ln>
-          <a:effectLst/>
-        </p:spPr>
-        <p:style>
-          <a:lnRef idx="1">
-            <a:schemeClr val="accent1"/>
-          </a:lnRef>
-          <a:fillRef idx="3">
-            <a:schemeClr val="accent1"/>
-          </a:fillRef>
-          <a:effectRef idx="2">
-            <a:schemeClr val="accent1"/>
-          </a:effectRef>
-          <a:fontRef idx="minor">
-            <a:schemeClr val="lt1"/>
-          </a:fontRef>
-        </p:style>
-        <p:txBody>
-          <a:bodyPr rtlCol="0" anchor="ctr" wrap="none" lIns="0" rIns="0" tIns="0" bIns="0"/>
-          <a:lstStyle/>
-          <a:p>
-            <a:pPr algn="ctr"/>
-            <a:r>
-              <a:rPr sz="1400" b="1">
-                <a:solidFill>
-                  <a:srgbClr val="FFFFFF"/>
-                </a:solidFill>
-                <a:latin typeface="Calibri"/>
-              </a:rPr>
-              <a:t>1</a:t>
-            </a:r>
-          </a:p>
-        </p:txBody>
-      </p:sp>
-      <p:sp>
-        <p:nvSpPr>
-          <p:cNvPr id="10" name="Rounded Rectangle 9"/>
-          <p:cNvSpPr/>
-          <p:nvPr/>
-        </p:nvSpPr>
-        <p:spPr>
-          <a:xfrm>
-            <a:off x="1417320" y="2724912"/>
-            <a:ext cx="10195560" cy="914400"/>
+            <a:off x="4343400" y="1600200"/>
+            <a:ext cx="3611880" cy="3063240"/>
           </a:xfrm>
           <a:prstGeom prst="roundRect">
             <a:avLst>
@@ -7178,161 +7174,209 @@
       </p:sp>
       <p:sp>
         <p:nvSpPr>
-          <p:cNvPr id="11" name="TextBox 10"/>
-          <p:cNvSpPr txBox="1"/>
-          <p:nvPr/>
-        </p:nvSpPr>
-        <p:spPr>
-          <a:xfrm>
-            <a:off x="1691640" y="2834640"/>
-            <a:ext cx="5943600" cy="365760"/>
-          </a:xfrm>
-          <a:prstGeom prst="rect">
-            <a:avLst/>
-          </a:prstGeom>
-          <a:noFill/>
-        </p:spPr>
-        <p:txBody>
-          <a:bodyPr wrap="square" lIns="0" rIns="0" tIns="0" bIns="0" anchor="t">
-            <a:spAutoFit/>
-          </a:bodyPr>
-          <a:lstStyle/>
-          <a:p>
-            <a:pPr algn="l">
-              <a:spcAft>
-                <a:spcPts val="0"/>
-              </a:spcAft>
-            </a:pPr>
-            <a:r>
-              <a:rPr sz="1500" b="1" i="0">
+          <p:cNvPr id="12" name="TextBox 11"/>
+          <p:cNvSpPr txBox="1"/>
+          <p:nvPr/>
+        </p:nvSpPr>
+        <p:spPr>
+          <a:xfrm>
+            <a:off x="4572000" y="1783080"/>
+            <a:ext cx="3200400" cy="320040"/>
+          </a:xfrm>
+          <a:prstGeom prst="rect">
+            <a:avLst/>
+          </a:prstGeom>
+          <a:noFill/>
+        </p:spPr>
+        <p:txBody>
+          <a:bodyPr wrap="square" lIns="0" rIns="0" tIns="0" bIns="0" anchor="t">
+            <a:spAutoFit/>
+          </a:bodyPr>
+          <a:lstStyle/>
+          <a:p>
+            <a:pPr algn="l">
+              <a:spcAft>
+                <a:spcPts val="600"/>
+              </a:spcAft>
+            </a:pPr>
+            <a:r>
+              <a:rPr sz="1450" b="1" i="0">
+                <a:solidFill>
+                  <a:srgbClr val="6B4FBB"/>
+                </a:solidFill>
+                <a:latin typeface="Calibri"/>
+              </a:rPr>
+              <a:t>Wave 2 · With 6–12 mo of data</a:t>
+            </a:r>
+          </a:p>
+        </p:txBody>
+      </p:sp>
+      <p:sp>
+        <p:nvSpPr>
+          <p:cNvPr id="13" name="TextBox 12"/>
+          <p:cNvSpPr txBox="1"/>
+          <p:nvPr/>
+        </p:nvSpPr>
+        <p:spPr>
+          <a:xfrm>
+            <a:off x="4572000" y="2240280"/>
+            <a:ext cx="3200400" cy="320040"/>
+          </a:xfrm>
+          <a:prstGeom prst="rect">
+            <a:avLst/>
+          </a:prstGeom>
+          <a:noFill/>
+        </p:spPr>
+        <p:txBody>
+          <a:bodyPr wrap="square" lIns="0" rIns="0" tIns="0" bIns="0" anchor="t">
+            <a:spAutoFit/>
+          </a:bodyPr>
+          <a:lstStyle/>
+          <a:p>
+            <a:pPr algn="l">
+              <a:spcAft>
+                <a:spcPts val="600"/>
+              </a:spcAft>
+            </a:pPr>
+            <a:r>
+              <a:rPr sz="1250" b="1" i="0">
                 <a:solidFill>
                   <a:srgbClr val="1A2420"/>
                 </a:solidFill>
                 <a:latin typeface="Calibri"/>
               </a:rPr>
-              <a:t>S/4 core   </a:t>
-            </a:r>
-          </a:p>
-          <a:p>
-            <a:pPr algn="l">
-              <a:spcAft>
-                <a:spcPts val="0"/>
+              <a:t>Channel &amp; send-time propensity</a:t>
+            </a:r>
+          </a:p>
+        </p:txBody>
+      </p:sp>
+      <p:sp>
+        <p:nvSpPr>
+          <p:cNvPr id="14" name="TextBox 13"/>
+          <p:cNvSpPr txBox="1"/>
+          <p:nvPr/>
+        </p:nvSpPr>
+        <p:spPr>
+          <a:xfrm>
+            <a:off x="4572000" y="2532888"/>
+            <a:ext cx="3200400" cy="868680"/>
+          </a:xfrm>
+          <a:prstGeom prst="rect">
+            <a:avLst/>
+          </a:prstGeom>
+          <a:noFill/>
+        </p:spPr>
+        <p:txBody>
+          <a:bodyPr wrap="square" lIns="0" rIns="0" tIns="0" bIns="0" anchor="t">
+            <a:spAutoFit/>
+          </a:bodyPr>
+          <a:lstStyle/>
+          <a:p>
+            <a:pPr algn="l">
+              <a:spcAft>
+                <a:spcPts val="600"/>
+              </a:spcAft>
+            </a:pPr>
+            <a:r>
+              <a:rPr sz="1030" b="0" i="0">
+                <a:solidFill>
+                  <a:srgbClr val="5B6A64"/>
+                </a:solidFill>
+                <a:latin typeface="Calibri"/>
+              </a:rPr>
+              <a:t>Learn what each customer responds to; surfaced as recommended defaults — decision stays in BRFplus</a:t>
+            </a:r>
+          </a:p>
+        </p:txBody>
+      </p:sp>
+      <p:sp>
+        <p:nvSpPr>
+          <p:cNvPr id="15" name="TextBox 14"/>
+          <p:cNvSpPr txBox="1"/>
+          <p:nvPr/>
+        </p:nvSpPr>
+        <p:spPr>
+          <a:xfrm>
+            <a:off x="4572000" y="3447288"/>
+            <a:ext cx="3200400" cy="320040"/>
+          </a:xfrm>
+          <a:prstGeom prst="rect">
+            <a:avLst/>
+          </a:prstGeom>
+          <a:noFill/>
+        </p:spPr>
+        <p:txBody>
+          <a:bodyPr wrap="square" lIns="0" rIns="0" tIns="0" bIns="0" anchor="t">
+            <a:spAutoFit/>
+          </a:bodyPr>
+          <a:lstStyle/>
+          <a:p>
+            <a:pPr algn="l">
+              <a:spcAft>
+                <a:spcPts val="600"/>
               </a:spcAft>
             </a:pPr>
             <a:r>
               <a:rPr sz="1250" b="1" i="0">
                 <a:solidFill>
-                  <a:srgbClr val="084A3E"/>
-                </a:solidFill>
-                <a:latin typeface="Calibri"/>
-              </a:rPr>
-              <a:t>6–8 wks</a:t>
-            </a:r>
-          </a:p>
-        </p:txBody>
-      </p:sp>
-      <p:sp>
-        <p:nvSpPr>
-          <p:cNvPr id="12" name="TextBox 11"/>
-          <p:cNvSpPr txBox="1"/>
-          <p:nvPr/>
-        </p:nvSpPr>
-        <p:spPr>
-          <a:xfrm>
-            <a:off x="1691640" y="3200400"/>
-            <a:ext cx="9692640" cy="411480"/>
-          </a:xfrm>
-          <a:prstGeom prst="rect">
-            <a:avLst/>
-          </a:prstGeom>
-          <a:noFill/>
-        </p:spPr>
-        <p:txBody>
-          <a:bodyPr wrap="square" lIns="0" rIns="0" tIns="0" bIns="0" anchor="t">
-            <a:spAutoFit/>
-          </a:bodyPr>
-          <a:lstStyle/>
-          <a:p>
-            <a:pPr algn="l">
-              <a:spcAft>
-                <a:spcPts val="600"/>
-              </a:spcAft>
-            </a:pPr>
-            <a:r>
-              <a:rPr sz="1150" b="0" i="0">
+                  <a:srgbClr val="1A2420"/>
+                </a:solidFill>
+                <a:latin typeface="Calibri"/>
+              </a:rPr>
+              <a:t>Opt-out / fatigue risk</a:t>
+            </a:r>
+          </a:p>
+        </p:txBody>
+      </p:sp>
+      <p:sp>
+        <p:nvSpPr>
+          <p:cNvPr id="16" name="TextBox 15"/>
+          <p:cNvSpPr txBox="1"/>
+          <p:nvPr/>
+        </p:nvSpPr>
+        <p:spPr>
+          <a:xfrm>
+            <a:off x="4572000" y="3739896"/>
+            <a:ext cx="3200400" cy="868680"/>
+          </a:xfrm>
+          <a:prstGeom prst="rect">
+            <a:avLst/>
+          </a:prstGeom>
+          <a:noFill/>
+        </p:spPr>
+        <p:txBody>
+          <a:bodyPr wrap="square" lIns="0" rIns="0" tIns="0" bIns="0" anchor="t">
+            <a:spAutoFit/>
+          </a:bodyPr>
+          <a:lstStyle/>
+          <a:p>
+            <a:pPr algn="l">
+              <a:spcAft>
+                <a:spcPts val="600"/>
+              </a:spcAft>
+            </a:pPr>
+            <a:r>
+              <a:rPr sz="1030" b="0" i="0">
                 <a:solidFill>
                   <a:srgbClr val="5B6A64"/>
                 </a:solidFill>
                 <a:latin typeface="Calibri"/>
               </a:rPr>
-              <a:t>Tables, CDS, RAP service, BRFplus app + seed content, event enhancements, roles</a:t>
-            </a:r>
-          </a:p>
-        </p:txBody>
-      </p:sp>
-      <p:sp>
-        <p:nvSpPr>
-          <p:cNvPr id="13" name="Oval 12"/>
+              <a:t>Throttle before one more message tips a customer into full DNC</a:t>
+            </a:r>
+          </a:p>
+        </p:txBody>
+      </p:sp>
+      <p:sp>
+        <p:nvSpPr>
+          <p:cNvPr id="17" name="Rounded Rectangle 16"/>
           <p:cNvSpPr/>
           <p:nvPr/>
         </p:nvSpPr>
         <p:spPr>
           <a:xfrm>
-            <a:off x="640080" y="4005072"/>
-            <a:ext cx="512064" cy="512064"/>
-          </a:xfrm>
-          <a:prstGeom prst="ellipse">
-            <a:avLst/>
-          </a:prstGeom>
-          <a:solidFill>
-            <a:srgbClr val="0A6E5C"/>
-          </a:solidFill>
-          <a:ln>
-            <a:noFill/>
-          </a:ln>
-          <a:effectLst/>
-        </p:spPr>
-        <p:style>
-          <a:lnRef idx="1">
-            <a:schemeClr val="accent1"/>
-          </a:lnRef>
-          <a:fillRef idx="3">
-            <a:schemeClr val="accent1"/>
-          </a:fillRef>
-          <a:effectRef idx="2">
-            <a:schemeClr val="accent1"/>
-          </a:effectRef>
-          <a:fontRef idx="minor">
-            <a:schemeClr val="lt1"/>
-          </a:fontRef>
-        </p:style>
-        <p:txBody>
-          <a:bodyPr rtlCol="0" anchor="ctr" wrap="none" lIns="0" rIns="0" tIns="0" bIns="0"/>
-          <a:lstStyle/>
-          <a:p>
-            <a:pPr algn="ctr"/>
-            <a:r>
-              <a:rPr sz="1400" b="1">
-                <a:solidFill>
-                  <a:srgbClr val="FFFFFF"/>
-                </a:solidFill>
-                <a:latin typeface="Calibri"/>
-              </a:rPr>
-              <a:t>2</a:t>
-            </a:r>
-          </a:p>
-        </p:txBody>
-      </p:sp>
-      <p:sp>
-        <p:nvSpPr>
-          <p:cNvPr id="14" name="Rounded Rectangle 13"/>
-          <p:cNvSpPr/>
-          <p:nvPr/>
-        </p:nvSpPr>
-        <p:spPr>
-          <a:xfrm>
-            <a:off x="1417320" y="3803904"/>
-            <a:ext cx="10195560" cy="914400"/>
+            <a:off x="8138160" y="1600200"/>
+            <a:ext cx="3611880" cy="3063240"/>
           </a:xfrm>
           <a:prstGeom prst="roundRect">
             <a:avLst>
@@ -7371,114 +7415,217 @@
       </p:sp>
       <p:sp>
         <p:nvSpPr>
-          <p:cNvPr id="15" name="TextBox 14"/>
-          <p:cNvSpPr txBox="1"/>
-          <p:nvPr/>
-        </p:nvSpPr>
-        <p:spPr>
-          <a:xfrm>
-            <a:off x="1691640" y="3913632"/>
-            <a:ext cx="5943600" cy="365760"/>
-          </a:xfrm>
-          <a:prstGeom prst="rect">
-            <a:avLst/>
-          </a:prstGeom>
-          <a:noFill/>
-        </p:spPr>
-        <p:txBody>
-          <a:bodyPr wrap="square" lIns="0" rIns="0" tIns="0" bIns="0" anchor="t">
-            <a:spAutoFit/>
-          </a:bodyPr>
-          <a:lstStyle/>
-          <a:p>
-            <a:pPr algn="l">
-              <a:spcAft>
-                <a:spcPts val="0"/>
-              </a:spcAft>
-            </a:pPr>
-            <a:r>
-              <a:rPr sz="1500" b="1" i="0">
+          <p:cNvPr id="18" name="TextBox 17"/>
+          <p:cNvSpPr txBox="1"/>
+          <p:nvPr/>
+        </p:nvSpPr>
+        <p:spPr>
+          <a:xfrm>
+            <a:off x="8366760" y="1783080"/>
+            <a:ext cx="3200400" cy="320040"/>
+          </a:xfrm>
+          <a:prstGeom prst="rect">
+            <a:avLst/>
+          </a:prstGeom>
+          <a:noFill/>
+        </p:spPr>
+        <p:txBody>
+          <a:bodyPr wrap="square" lIns="0" rIns="0" tIns="0" bIns="0" anchor="t">
+            <a:spAutoFit/>
+          </a:bodyPr>
+          <a:lstStyle/>
+          <a:p>
+            <a:pPr algn="l">
+              <a:spcAft>
+                <a:spcPts val="600"/>
+              </a:spcAft>
+            </a:pPr>
+            <a:r>
+              <a:rPr sz="1450" b="1" i="0">
+                <a:solidFill>
+                  <a:srgbClr val="6B4FBB"/>
+                </a:solidFill>
+                <a:latin typeface="Calibri"/>
+              </a:rPr>
+              <a:t>Wave 3 · Governance-mature</a:t>
+            </a:r>
+          </a:p>
+        </p:txBody>
+      </p:sp>
+      <p:sp>
+        <p:nvSpPr>
+          <p:cNvPr id="19" name="TextBox 18"/>
+          <p:cNvSpPr txBox="1"/>
+          <p:nvPr/>
+        </p:nvSpPr>
+        <p:spPr>
+          <a:xfrm>
+            <a:off x="8366760" y="2240280"/>
+            <a:ext cx="3200400" cy="320040"/>
+          </a:xfrm>
+          <a:prstGeom prst="rect">
+            <a:avLst/>
+          </a:prstGeom>
+          <a:noFill/>
+        </p:spPr>
+        <p:txBody>
+          <a:bodyPr wrap="square" lIns="0" rIns="0" tIns="0" bIns="0" anchor="t">
+            <a:spAutoFit/>
+          </a:bodyPr>
+          <a:lstStyle/>
+          <a:p>
+            <a:pPr algn="l">
+              <a:spcAft>
+                <a:spcPts val="600"/>
+              </a:spcAft>
+            </a:pPr>
+            <a:r>
+              <a:rPr sz="1250" b="1" i="0">
                 <a:solidFill>
                   <a:srgbClr val="1A2420"/>
                 </a:solidFill>
                 <a:latin typeface="Calibri"/>
               </a:rPr>
-              <a:t>BTP &amp; Service Cloud   </a:t>
-            </a:r>
-          </a:p>
-          <a:p>
-            <a:pPr algn="l">
-              <a:spcAft>
-                <a:spcPts val="0"/>
+              <a:t>Compliance anomaly detection</a:t>
+            </a:r>
+          </a:p>
+        </p:txBody>
+      </p:sp>
+      <p:sp>
+        <p:nvSpPr>
+          <p:cNvPr id="20" name="TextBox 19"/>
+          <p:cNvSpPr txBox="1"/>
+          <p:nvPr/>
+        </p:nvSpPr>
+        <p:spPr>
+          <a:xfrm>
+            <a:off x="8366760" y="2532888"/>
+            <a:ext cx="3200400" cy="868680"/>
+          </a:xfrm>
+          <a:prstGeom prst="rect">
+            <a:avLst/>
+          </a:prstGeom>
+          <a:noFill/>
+        </p:spPr>
+        <p:txBody>
+          <a:bodyPr wrap="square" lIns="0" rIns="0" tIns="0" bIns="0" anchor="t">
+            <a:spAutoFit/>
+          </a:bodyPr>
+          <a:lstStyle/>
+          <a:p>
+            <a:pPr algn="l">
+              <a:spcAft>
+                <a:spcPts val="600"/>
+              </a:spcAft>
+            </a:pPr>
+            <a:r>
+              <a:rPr sz="1030" b="0" i="0">
+                <a:solidFill>
+                  <a:srgbClr val="5B6A64"/>
+                </a:solidFill>
+                <a:latin typeface="Calibri"/>
+              </a:rPr>
+              <a:t>CSR bulk-change patterns, opt-out spikes, DNC drift</a:t>
+            </a:r>
+          </a:p>
+        </p:txBody>
+      </p:sp>
+      <p:sp>
+        <p:nvSpPr>
+          <p:cNvPr id="21" name="TextBox 20"/>
+          <p:cNvSpPr txBox="1"/>
+          <p:nvPr/>
+        </p:nvSpPr>
+        <p:spPr>
+          <a:xfrm>
+            <a:off x="8366760" y="3447288"/>
+            <a:ext cx="3200400" cy="320040"/>
+          </a:xfrm>
+          <a:prstGeom prst="rect">
+            <a:avLst/>
+          </a:prstGeom>
+          <a:noFill/>
+        </p:spPr>
+        <p:txBody>
+          <a:bodyPr wrap="square" lIns="0" rIns="0" tIns="0" bIns="0" anchor="t">
+            <a:spAutoFit/>
+          </a:bodyPr>
+          <a:lstStyle/>
+          <a:p>
+            <a:pPr algn="l">
+              <a:spcAft>
+                <a:spcPts val="600"/>
               </a:spcAft>
             </a:pPr>
             <a:r>
               <a:rPr sz="1250" b="1" i="0">
                 <a:solidFill>
-                  <a:srgbClr val="084A3E"/>
-                </a:solidFill>
-                <a:latin typeface="Calibri"/>
-              </a:rPr>
-              <a:t>3–4 wks</a:t>
-            </a:r>
-          </a:p>
-        </p:txBody>
-      </p:sp>
-      <p:sp>
-        <p:nvSpPr>
-          <p:cNvPr id="16" name="TextBox 15"/>
-          <p:cNvSpPr txBox="1"/>
-          <p:nvPr/>
-        </p:nvSpPr>
-        <p:spPr>
-          <a:xfrm>
-            <a:off x="1691640" y="4279392"/>
-            <a:ext cx="9692640" cy="411480"/>
-          </a:xfrm>
-          <a:prstGeom prst="rect">
-            <a:avLst/>
-          </a:prstGeom>
-          <a:noFill/>
-        </p:spPr>
-        <p:txBody>
-          <a:bodyPr wrap="square" lIns="0" rIns="0" tIns="0" bIns="0" anchor="t">
-            <a:spAutoFit/>
-          </a:bodyPr>
-          <a:lstStyle/>
-          <a:p>
-            <a:pPr algn="l">
-              <a:spcAft>
-                <a:spcPts val="600"/>
-              </a:spcAft>
-            </a:pPr>
-            <a:r>
-              <a:rPr sz="1150" b="0" i="0">
+                  <a:srgbClr val="1A2420"/>
+                </a:solidFill>
+                <a:latin typeface="Calibri"/>
+              </a:rPr>
+              <a:t>Template intelligence + Energy Advisor</a:t>
+            </a:r>
+          </a:p>
+        </p:txBody>
+      </p:sp>
+      <p:sp>
+        <p:nvSpPr>
+          <p:cNvPr id="22" name="TextBox 21"/>
+          <p:cNvSpPr txBox="1"/>
+          <p:nvPr/>
+        </p:nvSpPr>
+        <p:spPr>
+          <a:xfrm>
+            <a:off x="8366760" y="3739896"/>
+            <a:ext cx="3200400" cy="868680"/>
+          </a:xfrm>
+          <a:prstGeom prst="rect">
+            <a:avLst/>
+          </a:prstGeom>
+          <a:noFill/>
+        </p:spPr>
+        <p:txBody>
+          <a:bodyPr wrap="square" lIns="0" rIns="0" tIns="0" bIns="0" anchor="t">
+            <a:spAutoFit/>
+          </a:bodyPr>
+          <a:lstStyle/>
+          <a:p>
+            <a:pPr algn="l">
+              <a:spcAft>
+                <a:spcPts val="600"/>
+              </a:spcAft>
+            </a:pPr>
+            <a:r>
+              <a:rPr sz="1030" b="0" i="0">
                 <a:solidFill>
                   <a:srgbClr val="5B6A64"/>
                 </a:solidFill>
                 <a:latin typeface="Calibri"/>
               </a:rPr>
-              <a:t>Deploy iFlows, Event Mesh queues, destinations, mashup rollout, providers</a:t>
-            </a:r>
-          </a:p>
-        </p:txBody>
-      </p:sp>
-      <p:sp>
-        <p:nvSpPr>
-          <p:cNvPr id="17" name="Oval 16"/>
+              <a:t>Tone/translation variants (PAST_DUE excluded); rate Q&amp;A grounded in the deterministic engine</a:t>
+            </a:r>
+          </a:p>
+        </p:txBody>
+      </p:sp>
+      <p:sp>
+        <p:nvSpPr>
+          <p:cNvPr id="23" name="Rounded Rectangle 22"/>
           <p:cNvSpPr/>
           <p:nvPr/>
         </p:nvSpPr>
         <p:spPr>
           <a:xfrm>
-            <a:off x="640080" y="5084064"/>
-            <a:ext cx="512064" cy="512064"/>
-          </a:xfrm>
-          <a:prstGeom prst="ellipse">
-            <a:avLst/>
+            <a:off x="548640" y="4892040"/>
+            <a:ext cx="11064240" cy="1371600"/>
+          </a:xfrm>
+          <a:prstGeom prst="roundRect">
+            <a:avLst>
+              <a:gd name="adj" fmla="val 6000"/>
+            </a:avLst>
           </a:prstGeom>
           <a:solidFill>
-            <a:srgbClr val="0A6E5C"/>
+            <a:srgbClr val="EEEAF8"/>
           </a:solidFill>
           <a:ln>
             <a:noFill/>
@@ -7500,243 +7647,105 @@
           </a:fontRef>
         </p:style>
         <p:txBody>
-          <a:bodyPr rtlCol="0" anchor="ctr" wrap="none" lIns="0" rIns="0" tIns="0" bIns="0"/>
+          <a:bodyPr rtlCol="0" anchor="ctr"/>
           <a:lstStyle/>
           <a:p>
             <a:pPr algn="ctr"/>
-            <a:r>
-              <a:rPr sz="1400" b="1">
-                <a:solidFill>
-                  <a:srgbClr val="FFFFFF"/>
-                </a:solidFill>
-                <a:latin typeface="Calibri"/>
-              </a:rPr>
-              <a:t>3</a:t>
-            </a:r>
-          </a:p>
-        </p:txBody>
-      </p:sp>
-      <p:sp>
-        <p:nvSpPr>
-          <p:cNvPr id="18" name="Rounded Rectangle 17"/>
-          <p:cNvSpPr/>
-          <p:nvPr/>
-        </p:nvSpPr>
-        <p:spPr>
-          <a:xfrm>
-            <a:off x="1417320" y="4882896"/>
-            <a:ext cx="10195560" cy="914400"/>
-          </a:xfrm>
-          <a:prstGeom prst="roundRect">
-            <a:avLst>
-              <a:gd name="adj" fmla="val 6000"/>
-            </a:avLst>
-          </a:prstGeom>
-          <a:solidFill>
-            <a:srgbClr val="F4F7F5"/>
-          </a:solidFill>
-          <a:ln>
-            <a:noFill/>
-          </a:ln>
-          <a:effectLst/>
-        </p:spPr>
-        <p:style>
-          <a:lnRef idx="1">
-            <a:schemeClr val="accent1"/>
-          </a:lnRef>
-          <a:fillRef idx="3">
-            <a:schemeClr val="accent1"/>
-          </a:fillRef>
-          <a:effectRef idx="2">
-            <a:schemeClr val="accent1"/>
-          </a:effectRef>
-          <a:fontRef idx="minor">
-            <a:schemeClr val="lt1"/>
-          </a:fontRef>
-        </p:style>
-        <p:txBody>
-          <a:bodyPr rtlCol="0" anchor="ctr"/>
-          <a:lstStyle/>
-          <a:p>
-            <a:pPr algn="ctr"/>
-          </a:p>
-        </p:txBody>
-      </p:sp>
-      <p:sp>
-        <p:nvSpPr>
-          <p:cNvPr id="19" name="TextBox 18"/>
-          <p:cNvSpPr txBox="1"/>
-          <p:nvPr/>
-        </p:nvSpPr>
-        <p:spPr>
-          <a:xfrm>
-            <a:off x="1691640" y="4992624"/>
-            <a:ext cx="5943600" cy="365760"/>
-          </a:xfrm>
-          <a:prstGeom prst="rect">
-            <a:avLst/>
-          </a:prstGeom>
-          <a:noFill/>
-        </p:spPr>
-        <p:txBody>
-          <a:bodyPr wrap="square" lIns="0" rIns="0" tIns="0" bIns="0" anchor="t">
-            <a:spAutoFit/>
-          </a:bodyPr>
-          <a:lstStyle/>
-          <a:p>
-            <a:pPr algn="l">
-              <a:spcAft>
-                <a:spcPts val="0"/>
-              </a:spcAft>
-            </a:pPr>
-            <a:r>
-              <a:rPr sz="1500" b="1" i="0">
+          </a:p>
+        </p:txBody>
+      </p:sp>
+      <p:sp>
+        <p:nvSpPr>
+          <p:cNvPr id="24" name="TextBox 23"/>
+          <p:cNvSpPr txBox="1"/>
+          <p:nvPr/>
+        </p:nvSpPr>
+        <p:spPr>
+          <a:xfrm>
+            <a:off x="868680" y="5047488"/>
+            <a:ext cx="10424160" cy="320040"/>
+          </a:xfrm>
+          <a:prstGeom prst="rect">
+            <a:avLst/>
+          </a:prstGeom>
+          <a:noFill/>
+        </p:spPr>
+        <p:txBody>
+          <a:bodyPr wrap="square" lIns="0" rIns="0" tIns="0" bIns="0" anchor="t">
+            <a:spAutoFit/>
+          </a:bodyPr>
+          <a:lstStyle/>
+          <a:p>
+            <a:pPr algn="l">
+              <a:spcAft>
+                <a:spcPts val="600"/>
+              </a:spcAft>
+            </a:pPr>
+            <a:r>
+              <a:rPr sz="1400" b="1" i="0">
+                <a:solidFill>
+                  <a:srgbClr val="6B4FBB"/>
+                </a:solidFill>
+                <a:latin typeface="Calibri"/>
+              </a:rPr>
+              <a:t>Red lines (structural, not policy)</a:t>
+            </a:r>
+          </a:p>
+        </p:txBody>
+      </p:sp>
+      <p:sp>
+        <p:nvSpPr>
+          <p:cNvPr id="25" name="TextBox 24"/>
+          <p:cNvSpPr txBox="1"/>
+          <p:nvPr/>
+        </p:nvSpPr>
+        <p:spPr>
+          <a:xfrm>
+            <a:off x="868680" y="5413248"/>
+            <a:ext cx="10424160" cy="822960"/>
+          </a:xfrm>
+          <a:prstGeom prst="rect">
+            <a:avLst/>
+          </a:prstGeom>
+          <a:noFill/>
+        </p:spPr>
+        <p:txBody>
+          <a:bodyPr wrap="square" lIns="0" rIns="0" tIns="0" bIns="0" anchor="t">
+            <a:spAutoFit/>
+          </a:bodyPr>
+          <a:lstStyle/>
+          <a:p>
+            <a:pPr algn="l" indent="-137160" marL="137160">
+              <a:spcAft>
+                <a:spcPts val="600"/>
+              </a:spcAft>
+              <a:buChar char="•"/>
+            </a:pPr>
+            <a:r>
+              <a:rPr sz="1200" b="0" i="0">
                 <a:solidFill>
                   <a:srgbClr val="1A2420"/>
                 </a:solidFill>
                 <a:latin typeface="Calibri"/>
               </a:rPr>
-              <a:t>Migrate &amp; cut over   </a:t>
-            </a:r>
-          </a:p>
-          <a:p>
-            <a:pPr algn="l">
-              <a:spcAft>
-                <a:spcPts val="0"/>
-              </a:spcAft>
-            </a:pPr>
-            <a:r>
-              <a:rPr sz="1250" b="1" i="0">
-                <a:solidFill>
-                  <a:srgbClr val="084A3E"/>
-                </a:solidFill>
-                <a:latin typeface="Calibri"/>
-              </a:rPr>
-              <a:t>3–4 wks</a:t>
-            </a:r>
-          </a:p>
-        </p:txBody>
-      </p:sp>
-      <p:sp>
-        <p:nvSpPr>
-          <p:cNvPr id="20" name="TextBox 19"/>
-          <p:cNvSpPr txBox="1"/>
-          <p:nvPr/>
-        </p:nvSpPr>
-        <p:spPr>
-          <a:xfrm>
-            <a:off x="1691640" y="5358384"/>
-            <a:ext cx="9692640" cy="411480"/>
-          </a:xfrm>
-          <a:prstGeom prst="rect">
-            <a:avLst/>
-          </a:prstGeom>
-          <a:noFill/>
-        </p:spPr>
-        <p:txBody>
-          <a:bodyPr wrap="square" lIns="0" rIns="0" tIns="0" bIns="0" anchor="t">
-            <a:spAutoFit/>
-          </a:bodyPr>
-          <a:lstStyle/>
-          <a:p>
-            <a:pPr algn="l">
-              <a:spcAft>
-                <a:spcPts val="600"/>
-              </a:spcAft>
-            </a:pPr>
-            <a:r>
-              <a:rPr sz="1150" b="0" i="0">
-                <a:solidFill>
-                  <a:srgbClr val="5B6A64"/>
-                </a:solidFill>
-                <a:latin typeface="Calibri"/>
-              </a:rPr>
-              <a:t>Legacy preference migration, reconciliation, parallel-run, go-live</a:t>
-            </a:r>
-          </a:p>
-        </p:txBody>
-      </p:sp>
-      <p:sp>
-        <p:nvSpPr>
-          <p:cNvPr id="21" name="Rounded Rectangle 20"/>
-          <p:cNvSpPr/>
-          <p:nvPr/>
-        </p:nvSpPr>
-        <p:spPr>
-          <a:xfrm>
-            <a:off x="548640" y="6035040"/>
-            <a:ext cx="11064240" cy="502920"/>
-          </a:xfrm>
-          <a:prstGeom prst="roundRect">
-            <a:avLst>
-              <a:gd name="adj" fmla="val 6000"/>
-            </a:avLst>
-          </a:prstGeom>
-          <a:solidFill>
-            <a:srgbClr val="EAF2EF"/>
-          </a:solidFill>
-          <a:ln>
-            <a:noFill/>
-          </a:ln>
-          <a:effectLst/>
-        </p:spPr>
-        <p:style>
-          <a:lnRef idx="1">
-            <a:schemeClr val="accent1"/>
-          </a:lnRef>
-          <a:fillRef idx="3">
-            <a:schemeClr val="accent1"/>
-          </a:fillRef>
-          <a:effectRef idx="2">
-            <a:schemeClr val="accent1"/>
-          </a:effectRef>
-          <a:fontRef idx="minor">
-            <a:schemeClr val="lt1"/>
-          </a:fontRef>
-        </p:style>
-        <p:txBody>
-          <a:bodyPr rtlCol="0" anchor="ctr"/>
-          <a:lstStyle/>
-          <a:p>
-            <a:pPr algn="ctr"/>
-          </a:p>
-        </p:txBody>
-      </p:sp>
-      <p:sp>
-        <p:nvSpPr>
-          <p:cNvPr id="22" name="TextBox 21"/>
-          <p:cNvSpPr txBox="1"/>
-          <p:nvPr/>
-        </p:nvSpPr>
-        <p:spPr>
-          <a:xfrm>
-            <a:off x="868680" y="6126480"/>
-            <a:ext cx="10424160" cy="365760"/>
-          </a:xfrm>
-          <a:prstGeom prst="rect">
-            <a:avLst/>
-          </a:prstGeom>
-          <a:noFill/>
-        </p:spPr>
-        <p:txBody>
-          <a:bodyPr wrap="square" lIns="0" rIns="0" tIns="0" bIns="0" anchor="t">
-            <a:spAutoFit/>
-          </a:bodyPr>
-          <a:lstStyle/>
-          <a:p>
-            <a:pPr algn="l">
-              <a:spcAft>
-                <a:spcPts val="600"/>
-              </a:spcAft>
-            </a:pPr>
-            <a:r>
-              <a:rPr sz="1300" b="1" i="0">
-                <a:solidFill>
-                  <a:srgbClr val="084A3E"/>
-                </a:solidFill>
-                <a:latin typeface="Calibri"/>
-              </a:rPr>
-              <a:t>Total: ~13–18 weeks to production (Option A).  Option B (S/4 CRM WebClient front end) adds ~3 weeks.</a:t>
+              <a:t>AI never makes the send/suppress decision — BRFplus only.  AI never writes — every change passes confirmation, identity guard, validation and audit.</a:t>
+            </a:r>
+          </a:p>
+          <a:p>
+            <a:pPr algn="l" indent="-137160" marL="137160">
+              <a:spcAft>
+                <a:spcPts val="600"/>
+              </a:spcAft>
+              <a:buChar char="•"/>
+            </a:pPr>
+            <a:r>
+              <a:rPr sz="1200" b="0" i="0">
+                <a:solidFill>
+                  <a:srgbClr val="1A2420"/>
+                </a:solidFill>
+                <a:latin typeface="Calibri"/>
+              </a:rPr>
+              <a:t>Regulatory wording and financial figures stay outside generative scope. Consent gates AI data use — the CPC enforces its own AI governance.</a:t>
             </a:r>
           </a:p>
         </p:txBody>
@@ -7750,6 +7759,1003 @@
 </file>
 
 <file path=ppt/slides/slide14.xml><?xml version="1.0" encoding="utf-8"?>
+<p:sld xmlns:a="http://schemas.openxmlformats.org/drawingml/2006/main" xmlns:p="http://schemas.openxmlformats.org/presentationml/2006/main" xmlns:r="http://schemas.openxmlformats.org/officeDocument/2006/relationships">
+  <p:cSld>
+    <p:spTree>
+      <p:nvGrpSpPr>
+        <p:cNvPr id="1" name=""/>
+        <p:cNvGrpSpPr/>
+        <p:nvPr/>
+      </p:nvGrpSpPr>
+      <p:grpSpPr/>
+      <p:sp>
+        <p:nvSpPr>
+          <p:cNvPr id="2" name="Rectangle 1"/>
+          <p:cNvSpPr/>
+          <p:nvPr/>
+        </p:nvSpPr>
+        <p:spPr>
+          <a:xfrm>
+            <a:off x="0" y="0"/>
+            <a:ext cx="12191695" cy="6858000"/>
+          </a:xfrm>
+          <a:prstGeom prst="rect">
+            <a:avLst/>
+          </a:prstGeom>
+          <a:solidFill>
+            <a:srgbClr val="FFFFFF"/>
+          </a:solidFill>
+          <a:ln>
+            <a:noFill/>
+          </a:ln>
+          <a:effectLst/>
+        </p:spPr>
+        <p:style>
+          <a:lnRef idx="1">
+            <a:schemeClr val="accent1"/>
+          </a:lnRef>
+          <a:fillRef idx="3">
+            <a:schemeClr val="accent1"/>
+          </a:fillRef>
+          <a:effectRef idx="2">
+            <a:schemeClr val="accent1"/>
+          </a:effectRef>
+          <a:fontRef idx="minor">
+            <a:schemeClr val="lt1"/>
+          </a:fontRef>
+        </p:style>
+        <p:txBody>
+          <a:bodyPr rtlCol="0" anchor="ctr"/>
+          <a:lstStyle/>
+          <a:p>
+            <a:pPr algn="ctr"/>
+          </a:p>
+        </p:txBody>
+      </p:sp>
+      <p:sp>
+        <p:nvSpPr>
+          <p:cNvPr id="3" name="TextBox 2"/>
+          <p:cNvSpPr txBox="1"/>
+          <p:nvPr/>
+        </p:nvSpPr>
+        <p:spPr>
+          <a:xfrm>
+            <a:off x="548640" y="384048"/>
+            <a:ext cx="11064240" cy="685800"/>
+          </a:xfrm>
+          <a:prstGeom prst="rect">
+            <a:avLst/>
+          </a:prstGeom>
+          <a:noFill/>
+        </p:spPr>
+        <p:txBody>
+          <a:bodyPr wrap="square" lIns="0" rIns="0" tIns="0" bIns="0" anchor="t">
+            <a:spAutoFit/>
+          </a:bodyPr>
+          <a:lstStyle/>
+          <a:p>
+            <a:pPr algn="l">
+              <a:spcAft>
+                <a:spcPts val="600"/>
+              </a:spcAft>
+            </a:pPr>
+            <a:r>
+              <a:rPr sz="3200" b="1" i="0">
+                <a:solidFill>
+                  <a:srgbClr val="1A2420"/>
+                </a:solidFill>
+                <a:latin typeface="Calibri"/>
+              </a:rPr>
+              <a:t>Delivery plan</a:t>
+            </a:r>
+          </a:p>
+        </p:txBody>
+      </p:sp>
+      <p:sp>
+        <p:nvSpPr>
+          <p:cNvPr id="4" name="TextBox 3"/>
+          <p:cNvSpPr txBox="1"/>
+          <p:nvPr/>
+        </p:nvSpPr>
+        <p:spPr>
+          <a:xfrm>
+            <a:off x="548640" y="987552"/>
+            <a:ext cx="11064240" cy="365760"/>
+          </a:xfrm>
+          <a:prstGeom prst="rect">
+            <a:avLst/>
+          </a:prstGeom>
+          <a:noFill/>
+        </p:spPr>
+        <p:txBody>
+          <a:bodyPr wrap="square" lIns="0" rIns="0" tIns="0" bIns="0" anchor="t">
+            <a:spAutoFit/>
+          </a:bodyPr>
+          <a:lstStyle/>
+          <a:p>
+            <a:pPr algn="l">
+              <a:spcAft>
+                <a:spcPts val="600"/>
+              </a:spcAft>
+            </a:pPr>
+            <a:r>
+              <a:rPr sz="1400" b="0" i="0">
+                <a:solidFill>
+                  <a:srgbClr val="5B6A64"/>
+                </a:solidFill>
+                <a:latin typeface="Calibri"/>
+              </a:rPr>
+              <a:t>Indicative — refined in a one-week discovery that validates landscape-dependent items</a:t>
+            </a:r>
+          </a:p>
+        </p:txBody>
+      </p:sp>
+      <p:sp>
+        <p:nvSpPr>
+          <p:cNvPr id="5" name="Oval 4"/>
+          <p:cNvSpPr/>
+          <p:nvPr/>
+        </p:nvSpPr>
+        <p:spPr>
+          <a:xfrm>
+            <a:off x="640080" y="1847088"/>
+            <a:ext cx="512064" cy="512064"/>
+          </a:xfrm>
+          <a:prstGeom prst="ellipse">
+            <a:avLst/>
+          </a:prstGeom>
+          <a:solidFill>
+            <a:srgbClr val="B8791A"/>
+          </a:solidFill>
+          <a:ln>
+            <a:noFill/>
+          </a:ln>
+          <a:effectLst/>
+        </p:spPr>
+        <p:style>
+          <a:lnRef idx="1">
+            <a:schemeClr val="accent1"/>
+          </a:lnRef>
+          <a:fillRef idx="3">
+            <a:schemeClr val="accent1"/>
+          </a:fillRef>
+          <a:effectRef idx="2">
+            <a:schemeClr val="accent1"/>
+          </a:effectRef>
+          <a:fontRef idx="minor">
+            <a:schemeClr val="lt1"/>
+          </a:fontRef>
+        </p:style>
+        <p:txBody>
+          <a:bodyPr rtlCol="0" anchor="ctr" wrap="none" lIns="0" rIns="0" tIns="0" bIns="0"/>
+          <a:lstStyle/>
+          <a:p>
+            <a:pPr algn="ctr"/>
+            <a:r>
+              <a:rPr sz="1400" b="1">
+                <a:solidFill>
+                  <a:srgbClr val="FFFFFF"/>
+                </a:solidFill>
+                <a:latin typeface="Calibri"/>
+              </a:rPr>
+              <a:t>0</a:t>
+            </a:r>
+          </a:p>
+        </p:txBody>
+      </p:sp>
+      <p:sp>
+        <p:nvSpPr>
+          <p:cNvPr id="6" name="Rounded Rectangle 5"/>
+          <p:cNvSpPr/>
+          <p:nvPr/>
+        </p:nvSpPr>
+        <p:spPr>
+          <a:xfrm>
+            <a:off x="1417320" y="1645920"/>
+            <a:ext cx="10195560" cy="914400"/>
+          </a:xfrm>
+          <a:prstGeom prst="roundRect">
+            <a:avLst>
+              <a:gd name="adj" fmla="val 6000"/>
+            </a:avLst>
+          </a:prstGeom>
+          <a:solidFill>
+            <a:srgbClr val="F4F7F5"/>
+          </a:solidFill>
+          <a:ln>
+            <a:noFill/>
+          </a:ln>
+          <a:effectLst/>
+        </p:spPr>
+        <p:style>
+          <a:lnRef idx="1">
+            <a:schemeClr val="accent1"/>
+          </a:lnRef>
+          <a:fillRef idx="3">
+            <a:schemeClr val="accent1"/>
+          </a:fillRef>
+          <a:effectRef idx="2">
+            <a:schemeClr val="accent1"/>
+          </a:effectRef>
+          <a:fontRef idx="minor">
+            <a:schemeClr val="lt1"/>
+          </a:fontRef>
+        </p:style>
+        <p:txBody>
+          <a:bodyPr rtlCol="0" anchor="ctr"/>
+          <a:lstStyle/>
+          <a:p>
+            <a:pPr algn="ctr"/>
+          </a:p>
+        </p:txBody>
+      </p:sp>
+      <p:sp>
+        <p:nvSpPr>
+          <p:cNvPr id="7" name="TextBox 6"/>
+          <p:cNvSpPr txBox="1"/>
+          <p:nvPr/>
+        </p:nvSpPr>
+        <p:spPr>
+          <a:xfrm>
+            <a:off x="1691640" y="1755648"/>
+            <a:ext cx="5943600" cy="365760"/>
+          </a:xfrm>
+          <a:prstGeom prst="rect">
+            <a:avLst/>
+          </a:prstGeom>
+          <a:noFill/>
+        </p:spPr>
+        <p:txBody>
+          <a:bodyPr wrap="square" lIns="0" rIns="0" tIns="0" bIns="0" anchor="t">
+            <a:spAutoFit/>
+          </a:bodyPr>
+          <a:lstStyle/>
+          <a:p>
+            <a:pPr algn="l">
+              <a:spcAft>
+                <a:spcPts val="0"/>
+              </a:spcAft>
+            </a:pPr>
+            <a:r>
+              <a:rPr sz="1500" b="1" i="0">
+                <a:solidFill>
+                  <a:srgbClr val="1A2420"/>
+                </a:solidFill>
+                <a:latin typeface="Calibri"/>
+              </a:rPr>
+              <a:t>Discovery &amp; validation   </a:t>
+            </a:r>
+          </a:p>
+          <a:p>
+            <a:pPr algn="l">
+              <a:spcAft>
+                <a:spcPts val="0"/>
+              </a:spcAft>
+            </a:pPr>
+            <a:r>
+              <a:rPr sz="1250" b="1" i="0">
+                <a:solidFill>
+                  <a:srgbClr val="084A3E"/>
+                </a:solidFill>
+                <a:latin typeface="Calibri"/>
+              </a:rPr>
+              <a:t>~1 wk</a:t>
+            </a:r>
+          </a:p>
+        </p:txBody>
+      </p:sp>
+      <p:sp>
+        <p:nvSpPr>
+          <p:cNvPr id="8" name="TextBox 7"/>
+          <p:cNvSpPr txBox="1"/>
+          <p:nvPr/>
+        </p:nvSpPr>
+        <p:spPr>
+          <a:xfrm>
+            <a:off x="1691640" y="2121408"/>
+            <a:ext cx="9692640" cy="411480"/>
+          </a:xfrm>
+          <a:prstGeom prst="rect">
+            <a:avLst/>
+          </a:prstGeom>
+          <a:noFill/>
+        </p:spPr>
+        <p:txBody>
+          <a:bodyPr wrap="square" lIns="0" rIns="0" tIns="0" bIns="0" anchor="t">
+            <a:spAutoFit/>
+          </a:bodyPr>
+          <a:lstStyle/>
+          <a:p>
+            <a:pPr algn="l">
+              <a:spcAft>
+                <a:spcPts val="600"/>
+              </a:spcAft>
+            </a:pPr>
+            <a:r>
+              <a:rPr sz="1150" b="0" i="0">
+                <a:solidFill>
+                  <a:srgbClr val="5B6A64"/>
+                </a:solidFill>
+                <a:latin typeface="Calibri"/>
+              </a:rPr>
+              <a:t>Confirm S/4 release APIs &amp; event mechanism, option A/B, master-data source, workbook sign-off</a:t>
+            </a:r>
+          </a:p>
+        </p:txBody>
+      </p:sp>
+      <p:sp>
+        <p:nvSpPr>
+          <p:cNvPr id="9" name="Oval 8"/>
+          <p:cNvSpPr/>
+          <p:nvPr/>
+        </p:nvSpPr>
+        <p:spPr>
+          <a:xfrm>
+            <a:off x="640080" y="2926080"/>
+            <a:ext cx="512064" cy="512064"/>
+          </a:xfrm>
+          <a:prstGeom prst="ellipse">
+            <a:avLst/>
+          </a:prstGeom>
+          <a:solidFill>
+            <a:srgbClr val="0A6E5C"/>
+          </a:solidFill>
+          <a:ln>
+            <a:noFill/>
+          </a:ln>
+          <a:effectLst/>
+        </p:spPr>
+        <p:style>
+          <a:lnRef idx="1">
+            <a:schemeClr val="accent1"/>
+          </a:lnRef>
+          <a:fillRef idx="3">
+            <a:schemeClr val="accent1"/>
+          </a:fillRef>
+          <a:effectRef idx="2">
+            <a:schemeClr val="accent1"/>
+          </a:effectRef>
+          <a:fontRef idx="minor">
+            <a:schemeClr val="lt1"/>
+          </a:fontRef>
+        </p:style>
+        <p:txBody>
+          <a:bodyPr rtlCol="0" anchor="ctr" wrap="none" lIns="0" rIns="0" tIns="0" bIns="0"/>
+          <a:lstStyle/>
+          <a:p>
+            <a:pPr algn="ctr"/>
+            <a:r>
+              <a:rPr sz="1400" b="1">
+                <a:solidFill>
+                  <a:srgbClr val="FFFFFF"/>
+                </a:solidFill>
+                <a:latin typeface="Calibri"/>
+              </a:rPr>
+              <a:t>1</a:t>
+            </a:r>
+          </a:p>
+        </p:txBody>
+      </p:sp>
+      <p:sp>
+        <p:nvSpPr>
+          <p:cNvPr id="10" name="Rounded Rectangle 9"/>
+          <p:cNvSpPr/>
+          <p:nvPr/>
+        </p:nvSpPr>
+        <p:spPr>
+          <a:xfrm>
+            <a:off x="1417320" y="2724912"/>
+            <a:ext cx="10195560" cy="914400"/>
+          </a:xfrm>
+          <a:prstGeom prst="roundRect">
+            <a:avLst>
+              <a:gd name="adj" fmla="val 6000"/>
+            </a:avLst>
+          </a:prstGeom>
+          <a:solidFill>
+            <a:srgbClr val="F4F7F5"/>
+          </a:solidFill>
+          <a:ln>
+            <a:noFill/>
+          </a:ln>
+          <a:effectLst/>
+        </p:spPr>
+        <p:style>
+          <a:lnRef idx="1">
+            <a:schemeClr val="accent1"/>
+          </a:lnRef>
+          <a:fillRef idx="3">
+            <a:schemeClr val="accent1"/>
+          </a:fillRef>
+          <a:effectRef idx="2">
+            <a:schemeClr val="accent1"/>
+          </a:effectRef>
+          <a:fontRef idx="minor">
+            <a:schemeClr val="lt1"/>
+          </a:fontRef>
+        </p:style>
+        <p:txBody>
+          <a:bodyPr rtlCol="0" anchor="ctr"/>
+          <a:lstStyle/>
+          <a:p>
+            <a:pPr algn="ctr"/>
+          </a:p>
+        </p:txBody>
+      </p:sp>
+      <p:sp>
+        <p:nvSpPr>
+          <p:cNvPr id="11" name="TextBox 10"/>
+          <p:cNvSpPr txBox="1"/>
+          <p:nvPr/>
+        </p:nvSpPr>
+        <p:spPr>
+          <a:xfrm>
+            <a:off x="1691640" y="2834640"/>
+            <a:ext cx="5943600" cy="365760"/>
+          </a:xfrm>
+          <a:prstGeom prst="rect">
+            <a:avLst/>
+          </a:prstGeom>
+          <a:noFill/>
+        </p:spPr>
+        <p:txBody>
+          <a:bodyPr wrap="square" lIns="0" rIns="0" tIns="0" bIns="0" anchor="t">
+            <a:spAutoFit/>
+          </a:bodyPr>
+          <a:lstStyle/>
+          <a:p>
+            <a:pPr algn="l">
+              <a:spcAft>
+                <a:spcPts val="0"/>
+              </a:spcAft>
+            </a:pPr>
+            <a:r>
+              <a:rPr sz="1500" b="1" i="0">
+                <a:solidFill>
+                  <a:srgbClr val="1A2420"/>
+                </a:solidFill>
+                <a:latin typeface="Calibri"/>
+              </a:rPr>
+              <a:t>S/4 core   </a:t>
+            </a:r>
+          </a:p>
+          <a:p>
+            <a:pPr algn="l">
+              <a:spcAft>
+                <a:spcPts val="0"/>
+              </a:spcAft>
+            </a:pPr>
+            <a:r>
+              <a:rPr sz="1250" b="1" i="0">
+                <a:solidFill>
+                  <a:srgbClr val="084A3E"/>
+                </a:solidFill>
+                <a:latin typeface="Calibri"/>
+              </a:rPr>
+              <a:t>6–8 wks</a:t>
+            </a:r>
+          </a:p>
+        </p:txBody>
+      </p:sp>
+      <p:sp>
+        <p:nvSpPr>
+          <p:cNvPr id="12" name="TextBox 11"/>
+          <p:cNvSpPr txBox="1"/>
+          <p:nvPr/>
+        </p:nvSpPr>
+        <p:spPr>
+          <a:xfrm>
+            <a:off x="1691640" y="3200400"/>
+            <a:ext cx="9692640" cy="411480"/>
+          </a:xfrm>
+          <a:prstGeom prst="rect">
+            <a:avLst/>
+          </a:prstGeom>
+          <a:noFill/>
+        </p:spPr>
+        <p:txBody>
+          <a:bodyPr wrap="square" lIns="0" rIns="0" tIns="0" bIns="0" anchor="t">
+            <a:spAutoFit/>
+          </a:bodyPr>
+          <a:lstStyle/>
+          <a:p>
+            <a:pPr algn="l">
+              <a:spcAft>
+                <a:spcPts val="600"/>
+              </a:spcAft>
+            </a:pPr>
+            <a:r>
+              <a:rPr sz="1150" b="0" i="0">
+                <a:solidFill>
+                  <a:srgbClr val="5B6A64"/>
+                </a:solidFill>
+                <a:latin typeface="Calibri"/>
+              </a:rPr>
+              <a:t>Tables, CDS, RAP service, BRFplus app + seed content, event enhancements, roles</a:t>
+            </a:r>
+          </a:p>
+        </p:txBody>
+      </p:sp>
+      <p:sp>
+        <p:nvSpPr>
+          <p:cNvPr id="13" name="Oval 12"/>
+          <p:cNvSpPr/>
+          <p:nvPr/>
+        </p:nvSpPr>
+        <p:spPr>
+          <a:xfrm>
+            <a:off x="640080" y="4005072"/>
+            <a:ext cx="512064" cy="512064"/>
+          </a:xfrm>
+          <a:prstGeom prst="ellipse">
+            <a:avLst/>
+          </a:prstGeom>
+          <a:solidFill>
+            <a:srgbClr val="0A6E5C"/>
+          </a:solidFill>
+          <a:ln>
+            <a:noFill/>
+          </a:ln>
+          <a:effectLst/>
+        </p:spPr>
+        <p:style>
+          <a:lnRef idx="1">
+            <a:schemeClr val="accent1"/>
+          </a:lnRef>
+          <a:fillRef idx="3">
+            <a:schemeClr val="accent1"/>
+          </a:fillRef>
+          <a:effectRef idx="2">
+            <a:schemeClr val="accent1"/>
+          </a:effectRef>
+          <a:fontRef idx="minor">
+            <a:schemeClr val="lt1"/>
+          </a:fontRef>
+        </p:style>
+        <p:txBody>
+          <a:bodyPr rtlCol="0" anchor="ctr" wrap="none" lIns="0" rIns="0" tIns="0" bIns="0"/>
+          <a:lstStyle/>
+          <a:p>
+            <a:pPr algn="ctr"/>
+            <a:r>
+              <a:rPr sz="1400" b="1">
+                <a:solidFill>
+                  <a:srgbClr val="FFFFFF"/>
+                </a:solidFill>
+                <a:latin typeface="Calibri"/>
+              </a:rPr>
+              <a:t>2</a:t>
+            </a:r>
+          </a:p>
+        </p:txBody>
+      </p:sp>
+      <p:sp>
+        <p:nvSpPr>
+          <p:cNvPr id="14" name="Rounded Rectangle 13"/>
+          <p:cNvSpPr/>
+          <p:nvPr/>
+        </p:nvSpPr>
+        <p:spPr>
+          <a:xfrm>
+            <a:off x="1417320" y="3803904"/>
+            <a:ext cx="10195560" cy="914400"/>
+          </a:xfrm>
+          <a:prstGeom prst="roundRect">
+            <a:avLst>
+              <a:gd name="adj" fmla="val 6000"/>
+            </a:avLst>
+          </a:prstGeom>
+          <a:solidFill>
+            <a:srgbClr val="F4F7F5"/>
+          </a:solidFill>
+          <a:ln>
+            <a:noFill/>
+          </a:ln>
+          <a:effectLst/>
+        </p:spPr>
+        <p:style>
+          <a:lnRef idx="1">
+            <a:schemeClr val="accent1"/>
+          </a:lnRef>
+          <a:fillRef idx="3">
+            <a:schemeClr val="accent1"/>
+          </a:fillRef>
+          <a:effectRef idx="2">
+            <a:schemeClr val="accent1"/>
+          </a:effectRef>
+          <a:fontRef idx="minor">
+            <a:schemeClr val="lt1"/>
+          </a:fontRef>
+        </p:style>
+        <p:txBody>
+          <a:bodyPr rtlCol="0" anchor="ctr"/>
+          <a:lstStyle/>
+          <a:p>
+            <a:pPr algn="ctr"/>
+          </a:p>
+        </p:txBody>
+      </p:sp>
+      <p:sp>
+        <p:nvSpPr>
+          <p:cNvPr id="15" name="TextBox 14"/>
+          <p:cNvSpPr txBox="1"/>
+          <p:nvPr/>
+        </p:nvSpPr>
+        <p:spPr>
+          <a:xfrm>
+            <a:off x="1691640" y="3913632"/>
+            <a:ext cx="5943600" cy="365760"/>
+          </a:xfrm>
+          <a:prstGeom prst="rect">
+            <a:avLst/>
+          </a:prstGeom>
+          <a:noFill/>
+        </p:spPr>
+        <p:txBody>
+          <a:bodyPr wrap="square" lIns="0" rIns="0" tIns="0" bIns="0" anchor="t">
+            <a:spAutoFit/>
+          </a:bodyPr>
+          <a:lstStyle/>
+          <a:p>
+            <a:pPr algn="l">
+              <a:spcAft>
+                <a:spcPts val="0"/>
+              </a:spcAft>
+            </a:pPr>
+            <a:r>
+              <a:rPr sz="1500" b="1" i="0">
+                <a:solidFill>
+                  <a:srgbClr val="1A2420"/>
+                </a:solidFill>
+                <a:latin typeface="Calibri"/>
+              </a:rPr>
+              <a:t>BTP &amp; Service Cloud   </a:t>
+            </a:r>
+          </a:p>
+          <a:p>
+            <a:pPr algn="l">
+              <a:spcAft>
+                <a:spcPts val="0"/>
+              </a:spcAft>
+            </a:pPr>
+            <a:r>
+              <a:rPr sz="1250" b="1" i="0">
+                <a:solidFill>
+                  <a:srgbClr val="084A3E"/>
+                </a:solidFill>
+                <a:latin typeface="Calibri"/>
+              </a:rPr>
+              <a:t>3–4 wks</a:t>
+            </a:r>
+          </a:p>
+        </p:txBody>
+      </p:sp>
+      <p:sp>
+        <p:nvSpPr>
+          <p:cNvPr id="16" name="TextBox 15"/>
+          <p:cNvSpPr txBox="1"/>
+          <p:nvPr/>
+        </p:nvSpPr>
+        <p:spPr>
+          <a:xfrm>
+            <a:off x="1691640" y="4279392"/>
+            <a:ext cx="9692640" cy="411480"/>
+          </a:xfrm>
+          <a:prstGeom prst="rect">
+            <a:avLst/>
+          </a:prstGeom>
+          <a:noFill/>
+        </p:spPr>
+        <p:txBody>
+          <a:bodyPr wrap="square" lIns="0" rIns="0" tIns="0" bIns="0" anchor="t">
+            <a:spAutoFit/>
+          </a:bodyPr>
+          <a:lstStyle/>
+          <a:p>
+            <a:pPr algn="l">
+              <a:spcAft>
+                <a:spcPts val="600"/>
+              </a:spcAft>
+            </a:pPr>
+            <a:r>
+              <a:rPr sz="1150" b="0" i="0">
+                <a:solidFill>
+                  <a:srgbClr val="5B6A64"/>
+                </a:solidFill>
+                <a:latin typeface="Calibri"/>
+              </a:rPr>
+              <a:t>Deploy iFlows, Event Mesh queues, destinations, mashup rollout, providers</a:t>
+            </a:r>
+          </a:p>
+        </p:txBody>
+      </p:sp>
+      <p:sp>
+        <p:nvSpPr>
+          <p:cNvPr id="17" name="Oval 16"/>
+          <p:cNvSpPr/>
+          <p:nvPr/>
+        </p:nvSpPr>
+        <p:spPr>
+          <a:xfrm>
+            <a:off x="640080" y="5084064"/>
+            <a:ext cx="512064" cy="512064"/>
+          </a:xfrm>
+          <a:prstGeom prst="ellipse">
+            <a:avLst/>
+          </a:prstGeom>
+          <a:solidFill>
+            <a:srgbClr val="0A6E5C"/>
+          </a:solidFill>
+          <a:ln>
+            <a:noFill/>
+          </a:ln>
+          <a:effectLst/>
+        </p:spPr>
+        <p:style>
+          <a:lnRef idx="1">
+            <a:schemeClr val="accent1"/>
+          </a:lnRef>
+          <a:fillRef idx="3">
+            <a:schemeClr val="accent1"/>
+          </a:fillRef>
+          <a:effectRef idx="2">
+            <a:schemeClr val="accent1"/>
+          </a:effectRef>
+          <a:fontRef idx="minor">
+            <a:schemeClr val="lt1"/>
+          </a:fontRef>
+        </p:style>
+        <p:txBody>
+          <a:bodyPr rtlCol="0" anchor="ctr" wrap="none" lIns="0" rIns="0" tIns="0" bIns="0"/>
+          <a:lstStyle/>
+          <a:p>
+            <a:pPr algn="ctr"/>
+            <a:r>
+              <a:rPr sz="1400" b="1">
+                <a:solidFill>
+                  <a:srgbClr val="FFFFFF"/>
+                </a:solidFill>
+                <a:latin typeface="Calibri"/>
+              </a:rPr>
+              <a:t>3</a:t>
+            </a:r>
+          </a:p>
+        </p:txBody>
+      </p:sp>
+      <p:sp>
+        <p:nvSpPr>
+          <p:cNvPr id="18" name="Rounded Rectangle 17"/>
+          <p:cNvSpPr/>
+          <p:nvPr/>
+        </p:nvSpPr>
+        <p:spPr>
+          <a:xfrm>
+            <a:off x="1417320" y="4882896"/>
+            <a:ext cx="10195560" cy="914400"/>
+          </a:xfrm>
+          <a:prstGeom prst="roundRect">
+            <a:avLst>
+              <a:gd name="adj" fmla="val 6000"/>
+            </a:avLst>
+          </a:prstGeom>
+          <a:solidFill>
+            <a:srgbClr val="F4F7F5"/>
+          </a:solidFill>
+          <a:ln>
+            <a:noFill/>
+          </a:ln>
+          <a:effectLst/>
+        </p:spPr>
+        <p:style>
+          <a:lnRef idx="1">
+            <a:schemeClr val="accent1"/>
+          </a:lnRef>
+          <a:fillRef idx="3">
+            <a:schemeClr val="accent1"/>
+          </a:fillRef>
+          <a:effectRef idx="2">
+            <a:schemeClr val="accent1"/>
+          </a:effectRef>
+          <a:fontRef idx="minor">
+            <a:schemeClr val="lt1"/>
+          </a:fontRef>
+        </p:style>
+        <p:txBody>
+          <a:bodyPr rtlCol="0" anchor="ctr"/>
+          <a:lstStyle/>
+          <a:p>
+            <a:pPr algn="ctr"/>
+          </a:p>
+        </p:txBody>
+      </p:sp>
+      <p:sp>
+        <p:nvSpPr>
+          <p:cNvPr id="19" name="TextBox 18"/>
+          <p:cNvSpPr txBox="1"/>
+          <p:nvPr/>
+        </p:nvSpPr>
+        <p:spPr>
+          <a:xfrm>
+            <a:off x="1691640" y="4992624"/>
+            <a:ext cx="5943600" cy="365760"/>
+          </a:xfrm>
+          <a:prstGeom prst="rect">
+            <a:avLst/>
+          </a:prstGeom>
+          <a:noFill/>
+        </p:spPr>
+        <p:txBody>
+          <a:bodyPr wrap="square" lIns="0" rIns="0" tIns="0" bIns="0" anchor="t">
+            <a:spAutoFit/>
+          </a:bodyPr>
+          <a:lstStyle/>
+          <a:p>
+            <a:pPr algn="l">
+              <a:spcAft>
+                <a:spcPts val="0"/>
+              </a:spcAft>
+            </a:pPr>
+            <a:r>
+              <a:rPr sz="1500" b="1" i="0">
+                <a:solidFill>
+                  <a:srgbClr val="1A2420"/>
+                </a:solidFill>
+                <a:latin typeface="Calibri"/>
+              </a:rPr>
+              <a:t>Migrate &amp; cut over   </a:t>
+            </a:r>
+          </a:p>
+          <a:p>
+            <a:pPr algn="l">
+              <a:spcAft>
+                <a:spcPts val="0"/>
+              </a:spcAft>
+            </a:pPr>
+            <a:r>
+              <a:rPr sz="1250" b="1" i="0">
+                <a:solidFill>
+                  <a:srgbClr val="084A3E"/>
+                </a:solidFill>
+                <a:latin typeface="Calibri"/>
+              </a:rPr>
+              <a:t>3–4 wks</a:t>
+            </a:r>
+          </a:p>
+        </p:txBody>
+      </p:sp>
+      <p:sp>
+        <p:nvSpPr>
+          <p:cNvPr id="20" name="TextBox 19"/>
+          <p:cNvSpPr txBox="1"/>
+          <p:nvPr/>
+        </p:nvSpPr>
+        <p:spPr>
+          <a:xfrm>
+            <a:off x="1691640" y="5358384"/>
+            <a:ext cx="9692640" cy="411480"/>
+          </a:xfrm>
+          <a:prstGeom prst="rect">
+            <a:avLst/>
+          </a:prstGeom>
+          <a:noFill/>
+        </p:spPr>
+        <p:txBody>
+          <a:bodyPr wrap="square" lIns="0" rIns="0" tIns="0" bIns="0" anchor="t">
+            <a:spAutoFit/>
+          </a:bodyPr>
+          <a:lstStyle/>
+          <a:p>
+            <a:pPr algn="l">
+              <a:spcAft>
+                <a:spcPts val="600"/>
+              </a:spcAft>
+            </a:pPr>
+            <a:r>
+              <a:rPr sz="1150" b="0" i="0">
+                <a:solidFill>
+                  <a:srgbClr val="5B6A64"/>
+                </a:solidFill>
+                <a:latin typeface="Calibri"/>
+              </a:rPr>
+              <a:t>Legacy preference migration, reconciliation, parallel-run, go-live</a:t>
+            </a:r>
+          </a:p>
+        </p:txBody>
+      </p:sp>
+      <p:sp>
+        <p:nvSpPr>
+          <p:cNvPr id="21" name="Rounded Rectangle 20"/>
+          <p:cNvSpPr/>
+          <p:nvPr/>
+        </p:nvSpPr>
+        <p:spPr>
+          <a:xfrm>
+            <a:off x="548640" y="6035040"/>
+            <a:ext cx="11064240" cy="502920"/>
+          </a:xfrm>
+          <a:prstGeom prst="roundRect">
+            <a:avLst>
+              <a:gd name="adj" fmla="val 6000"/>
+            </a:avLst>
+          </a:prstGeom>
+          <a:solidFill>
+            <a:srgbClr val="EAF2EF"/>
+          </a:solidFill>
+          <a:ln>
+            <a:noFill/>
+          </a:ln>
+          <a:effectLst/>
+        </p:spPr>
+        <p:style>
+          <a:lnRef idx="1">
+            <a:schemeClr val="accent1"/>
+          </a:lnRef>
+          <a:fillRef idx="3">
+            <a:schemeClr val="accent1"/>
+          </a:fillRef>
+          <a:effectRef idx="2">
+            <a:schemeClr val="accent1"/>
+          </a:effectRef>
+          <a:fontRef idx="minor">
+            <a:schemeClr val="lt1"/>
+          </a:fontRef>
+        </p:style>
+        <p:txBody>
+          <a:bodyPr rtlCol="0" anchor="ctr"/>
+          <a:lstStyle/>
+          <a:p>
+            <a:pPr algn="ctr"/>
+          </a:p>
+        </p:txBody>
+      </p:sp>
+      <p:sp>
+        <p:nvSpPr>
+          <p:cNvPr id="22" name="TextBox 21"/>
+          <p:cNvSpPr txBox="1"/>
+          <p:nvPr/>
+        </p:nvSpPr>
+        <p:spPr>
+          <a:xfrm>
+            <a:off x="868680" y="6126480"/>
+            <a:ext cx="10424160" cy="365760"/>
+          </a:xfrm>
+          <a:prstGeom prst="rect">
+            <a:avLst/>
+          </a:prstGeom>
+          <a:noFill/>
+        </p:spPr>
+        <p:txBody>
+          <a:bodyPr wrap="square" lIns="0" rIns="0" tIns="0" bIns="0" anchor="t">
+            <a:spAutoFit/>
+          </a:bodyPr>
+          <a:lstStyle/>
+          <a:p>
+            <a:pPr algn="l">
+              <a:spcAft>
+                <a:spcPts val="600"/>
+              </a:spcAft>
+            </a:pPr>
+            <a:r>
+              <a:rPr sz="1300" b="1" i="0">
+                <a:solidFill>
+                  <a:srgbClr val="084A3E"/>
+                </a:solidFill>
+                <a:latin typeface="Calibri"/>
+              </a:rPr>
+              <a:t>Total: ~13–18 weeks to production (Option A).  Option B (S/4 CRM WebClient front end) adds ~3 weeks.</a:t>
+            </a:r>
+          </a:p>
+        </p:txBody>
+      </p:sp>
+    </p:spTree>
+  </p:cSld>
+  <p:clrMapOvr>
+    <a:masterClrMapping/>
+  </p:clrMapOvr>
+</p:sld>
+</file>
+
+<file path=ppt/slides/slide15.xml><?xml version="1.0" encoding="utf-8"?>
 <p:sld xmlns:a="http://schemas.openxmlformats.org/drawingml/2006/main" xmlns:p="http://schemas.openxmlformats.org/presentationml/2006/main" xmlns:r="http://schemas.openxmlformats.org/officeDocument/2006/relationships">
   <p:cSld>
     <p:spTree>

</xml_diff>